<commit_message>
Padroniza evidencias com visual Ubuntu e regenera docx/pptx
</commit_message>
<xml_diff>
--- a/docs/AP_II_DevSecOps_Apresentacao.pptx
+++ b/docs/AP_II_DevSecOps_Apresentacao.pptx
@@ -8446,7 +8446,7 @@
         <p:spPr>
           <a:xfrm>
             <a:off x="502920" y="1828800"/>
-            <a:ext cx="5486400" cy="1980092"/>
+            <a:ext cx="5486400" cy="2120168"/>
           </a:xfrm>
           <a:prstGeom prst="rect">
             <a:avLst/>
@@ -8470,7 +8470,7 @@
         <p:spPr>
           <a:xfrm>
             <a:off x="6263640" y="1828800"/>
-            <a:ext cx="5486400" cy="2399053"/>
+            <a:ext cx="5486400" cy="2566519"/>
           </a:xfrm>
           <a:prstGeom prst="rect">
             <a:avLst/>
@@ -8678,7 +8678,7 @@
         <p:spPr>
           <a:xfrm>
             <a:off x="502920" y="1828800"/>
-            <a:ext cx="5486400" cy="1980092"/>
+            <a:ext cx="5486400" cy="2120168"/>
           </a:xfrm>
           <a:prstGeom prst="rect">
             <a:avLst/>
@@ -8702,7 +8702,7 @@
         <p:spPr>
           <a:xfrm>
             <a:off x="6263640" y="1828800"/>
-            <a:ext cx="5486400" cy="1665871"/>
+            <a:ext cx="5486400" cy="1785405"/>
           </a:xfrm>
           <a:prstGeom prst="rect">
             <a:avLst/>
@@ -8910,7 +8910,7 @@
         <p:spPr>
           <a:xfrm>
             <a:off x="502920" y="1828800"/>
-            <a:ext cx="5486400" cy="1770611"/>
+            <a:ext cx="5486400" cy="1896993"/>
           </a:xfrm>
           <a:prstGeom prst="rect">
             <a:avLst/>
@@ -8934,7 +8934,7 @@
         <p:spPr>
           <a:xfrm>
             <a:off x="6263640" y="1828800"/>
-            <a:ext cx="5486400" cy="1351649"/>
+            <a:ext cx="5486400" cy="1450641"/>
           </a:xfrm>
           <a:prstGeom prst="rect">
             <a:avLst/>

</xml_diff>